<commit_message>
tune presentation: charts, titles, text
</commit_message>
<xml_diff>
--- a/docs/presentation.pptx
+++ b/docs/presentation.pptx
@@ -7253,20 +7253,12 @@
         </p:nvSpPr>
         <p:spPr/>
         <p:txBody>
-          <a:bodyPr wrap="square"/>
+          <a:bodyPr/>
           <a:lstStyle/>
           <a:p>
-            <a:pPr/>
-            <a:r>
-              <a:rPr sz="1500"/>
+            <a:r>
+              <a:rPr sz="1600"/>
               <a:t>Сухоплечев Виталий, Столярова Полина</a:t>
-            </a:r>
-          </a:p>
-          <a:p>
-            <a:pPr/>
-            <a:r>
-              <a:rPr sz="1500"/>
-              <a:t>Курс «Технологии ИИ», СПбГУ, 2 курс, весна 2026</a:t>
             </a:r>
           </a:p>
         </p:txBody>
@@ -7299,7 +7291,11 @@
             <p:ph type="title"/>
           </p:nvPr>
         </p:nvSpPr>
-        <p:spPr/>
+        <p:spPr>
+          <a:xfrm>
+            <a:ext cx="8500000" cy="0"/>
+          </a:xfrm>
+        </p:spPr>
         <p:txBody>
           <a:bodyPr/>
           <a:lstStyle/>
@@ -7498,7 +7494,11 @@
             <p:ph type="title"/>
           </p:nvPr>
         </p:nvSpPr>
-        <p:spPr/>
+        <p:spPr>
+          <a:xfrm>
+            <a:ext cx="8500000" cy="0"/>
+          </a:xfrm>
+        </p:spPr>
         <p:txBody>
           <a:bodyPr/>
           <a:lstStyle/>
@@ -7535,21 +7535,28 @@
             <a:pPr/>
             <a:r>
               <a:rPr sz="1100"/>
-              <a:t>Хорошо откалиброванная модель:</a:t>
+              <a:t>Идея калибровки:</a:t>
             </a:r>
           </a:p>
           <a:p>
             <a:pPr/>
             <a:r>
               <a:rPr sz="1100"/>
-              <a:t>если она говорит «70 % шанс»,</a:t>
+              <a:t>если модель говорит «70 % шанс»,</a:t>
             </a:r>
           </a:p>
           <a:p>
             <a:pPr/>
             <a:r>
               <a:rPr sz="1100"/>
-              <a:t>то в 70 % случаев так и будет.</a:t>
+              <a:t>то реально из таких броней</a:t>
+            </a:r>
+          </a:p>
+          <a:p>
+            <a:pPr/>
+            <a:r>
+              <a:rPr sz="1100"/>
+              <a:t>должно отмениться 70 %.</a:t>
             </a:r>
           </a:p>
           <a:p>
@@ -7563,7 +7570,14 @@
             <a:pPr/>
             <a:r>
               <a:rPr sz="1100"/>
-              <a:t>• Логистическая — почти идеально</a:t>
+              <a:t>• Логистическая регрессия —</a:t>
+            </a:r>
+          </a:p>
+          <a:p>
+            <a:pPr/>
+            <a:r>
+              <a:rPr sz="1100"/>
+              <a:t>   почти идеально</a:t>
             </a:r>
           </a:p>
           <a:p>
@@ -7584,14 +7598,14 @@
             <a:pPr/>
             <a:r>
               <a:rPr sz="1100"/>
-              <a:t>   уверенность (предсказал 0.9,</a:t>
+              <a:t>   уверенность: предсказал 0.9,</a:t>
             </a:r>
           </a:p>
           <a:p>
             <a:pPr/>
             <a:r>
               <a:rPr sz="1100"/>
-              <a:t>   реально доля = 0.7)</a:t>
+              <a:t>   а отменили только 70 %</a:t>
             </a:r>
           </a:p>
           <a:p>
@@ -7605,42 +7619,21 @@
             <a:pPr/>
             <a:r>
               <a:rPr sz="1100"/>
-              <a:t>• Градиентный бустинг —</a:t>
+              <a:t>• Градиентный бустинг — близко</a:t>
             </a:r>
           </a:p>
           <a:p>
             <a:pPr/>
             <a:r>
               <a:rPr sz="1100"/>
-              <a:t>   близко к идеалу, чуть</a:t>
+              <a:t>   к идеалу, чуть переоценивает</a:t>
             </a:r>
           </a:p>
           <a:p>
             <a:pPr/>
             <a:r>
               <a:rPr sz="1100"/>
-              <a:t>   переоценивает хвост</a:t>
-            </a:r>
-          </a:p>
-          <a:p>
-            <a:pPr/>
-            <a:r>
-              <a:rPr sz="1100"/>
-              <a:t/>
-            </a:r>
-          </a:p>
-          <a:p>
-            <a:pPr/>
-            <a:r>
-              <a:rPr sz="1100"/>
-              <a:t>Дополнительно выпрямляется</a:t>
-            </a:r>
-          </a:p>
-          <a:p>
-            <a:pPr/>
-            <a:r>
-              <a:rPr sz="1100"/>
-              <a:t>сигмоидой при необходимости.</a:t>
+              <a:t>   высокие вероятности</a:t>
             </a:r>
           </a:p>
         </p:txBody>
@@ -7697,7 +7690,11 @@
             <p:ph type="title"/>
           </p:nvPr>
         </p:nvSpPr>
-        <p:spPr/>
+        <p:spPr>
+          <a:xfrm>
+            <a:ext cx="8500000" cy="0"/>
+          </a:xfrm>
+        </p:spPr>
         <p:txBody>
           <a:bodyPr/>
           <a:lstStyle/>
@@ -7733,7 +7730,7 @@
           <a:p>
             <a:r>
               <a:rPr sz="1400" b="0"/>
-              <a:t>Запуск: run_app.bat → откроется в браузере по адресу localhost:8501</a:t>
+              <a:t>Запуск: run_app.bat — откроется в браузере на localhost:8501</a:t>
             </a:r>
           </a:p>
         </p:txBody>
@@ -7798,7 +7795,7 @@
             <a:pPr/>
             <a:r>
               <a:rPr sz="1200"/>
-              <a:t>   Модель выдаёт ≈ 99.8 % шанс отмены.</a:t>
+              <a:t>   Модель: примерно 99.8 % вероятность отмены.</a:t>
             </a:r>
           </a:p>
           <a:p>
@@ -7833,7 +7830,7 @@
             <a:pPr/>
             <a:r>
               <a:rPr sz="1200"/>
-              <a:t>   Модель выдаёт ≈ 0 %.</a:t>
+              <a:t>   Модель: примерно 0 % — клиент почти точно доедет.</a:t>
             </a:r>
           </a:p>
           <a:p>
@@ -7861,7 +7858,7 @@
             <a:pPr/>
             <a:r>
               <a:rPr sz="1200"/>
-              <a:t>   Модель ≈ 57 % — показывает, что граница не острая.</a:t>
+              <a:t>   Модель: около 57 % — граница риска не острая.</a:t>
             </a:r>
           </a:p>
           <a:p>
@@ -7875,14 +7872,14 @@
             <a:pPr/>
             <a:r>
               <a:rPr sz="1200"/>
-              <a:t>Можно вручную менять только срок до заезда (7 → 60 → 200) —</a:t>
+              <a:t>Дальше — ручная демонстрация: меняем только срок до заезда</a:t>
             </a:r>
           </a:p>
           <a:p>
             <a:pPr/>
             <a:r>
               <a:rPr sz="1200"/>
-              <a:t>вероятность отмены растёт почти монотонно.</a:t>
+              <a:t>(7 → 60 → 200 дней), вероятность отмены растёт почти монотонно.</a:t>
             </a:r>
           </a:p>
         </p:txBody>
@@ -7915,7 +7912,11 @@
             <p:ph type="title"/>
           </p:nvPr>
         </p:nvSpPr>
-        <p:spPr/>
+        <p:spPr>
+          <a:xfrm>
+            <a:ext cx="8500000" cy="0"/>
+          </a:xfrm>
+        </p:spPr>
         <p:txBody>
           <a:bodyPr/>
           <a:lstStyle/>
@@ -7951,7 +7952,7 @@
           <a:p>
             <a:r>
               <a:rPr sz="1400" b="0"/>
-              <a:t>Что нужно для работы в продакшене и какие у модели слабые места</a:t>
+              <a:t>Что нужно для работы в продакшене и слабые места модели</a:t>
             </a:r>
           </a:p>
         </p:txBody>
@@ -7988,14 +7989,14 @@
             <a:pPr/>
             <a:r>
               <a:rPr sz="1200"/>
-              <a:t>   простой веб-сервис (например на FastAPI) с командой /predict,</a:t>
+              <a:t>   простой веб-сервис (например, FastAPI) с командой /predict,</a:t>
             </a:r>
           </a:p>
           <a:p>
             <a:pPr/>
             <a:r>
               <a:rPr sz="1200"/>
-              <a:t>   модель загружается из файла в память при старте,</a:t>
+              <a:t>   модель загружается из файла в память при старте сервиса,</a:t>
             </a:r>
           </a:p>
           <a:p>
@@ -8009,7 +8010,7 @@
             <a:pPr/>
             <a:r>
               <a:rPr sz="1200"/>
-              <a:t>   раз в сутки — пересчёт по активным бронированиям,</a:t>
+              <a:t>   раз в сутки пересчёт по активным бронированиям,</a:t>
             </a:r>
           </a:p>
           <a:p>
@@ -8044,42 +8045,49 @@
             <a:pPr/>
             <a:r>
               <a:rPr sz="1200"/>
-              <a:t>   1. Перенос на другие отели. Учились на 2 отелях в Португалии —</a:t>
+              <a:t>   1. Перенос на другие отели. Обучались на двух отелях</a:t>
             </a:r>
           </a:p>
           <a:p>
             <a:pPr/>
             <a:r>
               <a:rPr sz="1200"/>
-              <a:t>      на сетевой отель в Германии может не перенестись.</a:t>
+              <a:t>      в Португалии — на сетевой отель в Германии может</a:t>
             </a:r>
           </a:p>
           <a:p>
             <a:pPr/>
             <a:r>
               <a:rPr sz="1200"/>
-              <a:t>   2. Смещение во времени. Данные 2015 – 2017, после ковида</a:t>
+              <a:t>      не перенестись.</a:t>
             </a:r>
           </a:p>
           <a:p>
             <a:pPr/>
             <a:r>
               <a:rPr sz="1200"/>
-              <a:t>      клиенты ведут себя иначе.</a:t>
+              <a:t>   2. Смещение во времени. Данные 2015 – 2017 годов,</a:t>
             </a:r>
           </a:p>
           <a:p>
             <a:pPr/>
             <a:r>
               <a:rPr sz="1200"/>
-              <a:t>   3. Новая страна. Для страны, которой не было в обучении,</a:t>
+              <a:t>      после ковида клиенты ведут себя иначе.</a:t>
             </a:r>
           </a:p>
           <a:p>
             <a:pPr/>
             <a:r>
               <a:rPr sz="1200"/>
-              <a:t>      целевое кодирование даст среднее по миру — точность падает.</a:t>
+              <a:t>   3. Новая страна. Если в обучении её не было, целевое</a:t>
+            </a:r>
+          </a:p>
+          <a:p>
+            <a:pPr/>
+            <a:r>
+              <a:rPr sz="1200"/>
+              <a:t>      кодирование даёт среднее по миру — точность падает.</a:t>
             </a:r>
           </a:p>
         </p:txBody>
@@ -8118,8 +8126,8 @@
           <a:lstStyle/>
           <a:p>
             <a:r>
-              <a:rPr sz="1400"/>
-              <a:t>Код, ноутбуки и отчёт — в репозитории. Готовы к вопросам.</a:t>
+              <a:rPr sz="100"/>
+              <a:t/>
             </a:r>
           </a:p>
         </p:txBody>
@@ -8140,7 +8148,37 @@
           <a:lstStyle/>
           <a:p>
             <a:r>
-              <a:rPr sz="2400" b="1"/>
+              <a:rPr sz="100"/>
+              <a:t/>
+            </a:r>
+          </a:p>
+        </p:txBody>
+      </p:sp>
+      <p:sp>
+        <p:nvSpPr>
+          <p:cNvPr id="4" name="TextBox 3"/>
+          <p:cNvSpPr txBox="1"/>
+          <p:nvPr/>
+        </p:nvSpPr>
+        <p:spPr>
+          <a:xfrm>
+            <a:off x="0" y="1800000"/>
+            <a:ext cx="9144000" cy="1500000"/>
+          </a:xfrm>
+          <a:prstGeom prst="rect">
+            <a:avLst/>
+          </a:prstGeom>
+          <a:noFill/>
+        </p:spPr>
+        <p:txBody>
+          <a:bodyPr wrap="square">
+            <a:spAutoFit/>
+          </a:bodyPr>
+          <a:lstStyle/>
+          <a:p>
+            <a:pPr algn="ctr"/>
+            <a:r>
+              <a:rPr sz="5400" b="1"/>
               <a:t>Спасибо за внимание</a:t>
             </a:r>
           </a:p>
@@ -8174,7 +8212,11 @@
             <p:ph type="title"/>
           </p:nvPr>
         </p:nvSpPr>
-        <p:spPr/>
+        <p:spPr>
+          <a:xfrm>
+            <a:ext cx="8500000" cy="0"/>
+          </a:xfrm>
+        </p:spPr>
         <p:txBody>
           <a:bodyPr/>
           <a:lstStyle/>
@@ -8240,7 +8282,7 @@
             <a:pPr/>
             <a:r>
               <a:rPr sz="1400"/>
-              <a:t>• Что предсказываем: 0 (доехал) или 1 (отменил)</a:t>
+              <a:t>• Что предсказываем: 0 — клиент доехал, 1 — отменил бронь</a:t>
             </a:r>
           </a:p>
           <a:p>
@@ -8254,7 +8296,7 @@
             <a:pPr/>
             <a:r>
               <a:rPr sz="1400"/>
-              <a:t>• Зачем отелю.</a:t>
+              <a:t>• Зачем это отелю.</a:t>
             </a:r>
           </a:p>
           <a:p>
@@ -8296,14 +8338,14 @@
             <a:pPr/>
             <a:r>
               <a:rPr sz="1400"/>
-              <a:t>   ROC-AUC (площадь под ROC-кривой) — основная метрика.</a:t>
+              <a:t>   ROC-AUC (площадь под ROC-кривой) — основная метрика,</a:t>
             </a:r>
           </a:p>
           <a:p>
             <a:pPr/>
             <a:r>
               <a:rPr sz="1400"/>
-              <a:t>   Она не зависит от выбранного порога принятия решения.</a:t>
+              <a:t>   не зависит от выбранного порога принятия решения.</a:t>
             </a:r>
           </a:p>
           <a:p>
@@ -8317,7 +8359,7 @@
             <a:pPr/>
             <a:r>
               <a:rPr sz="1400"/>
-              <a:t>   Полнота по классу «отмена» — дополнительная.</a:t>
+              <a:t>   Полнота по классу «отмена» — дополнительная метрика.</a:t>
             </a:r>
           </a:p>
           <a:p>
@@ -8357,7 +8399,11 @@
             <p:ph type="title"/>
           </p:nvPr>
         </p:nvSpPr>
-        <p:spPr/>
+        <p:spPr>
+          <a:xfrm>
+            <a:ext cx="8500000" cy="0"/>
+          </a:xfrm>
+        </p:spPr>
         <p:txBody>
           <a:bodyPr/>
           <a:lstStyle/>
@@ -8422,7 +8468,7 @@
             <a:pPr/>
             <a:r>
               <a:rPr sz="1400"/>
-              <a:t>• 32 признака</a:t>
+              <a:t>• 32 признака на бронь</a:t>
             </a:r>
           </a:p>
           <a:p>
@@ -8436,7 +8482,7 @@
             <a:pPr/>
             <a:r>
               <a:rPr sz="1400"/>
-              <a:t>• 2 отеля в Португалии:</a:t>
+              <a:t>• Два отеля в Португалии:</a:t>
             </a:r>
           </a:p>
           <a:p>
@@ -8457,7 +8503,7 @@
             <a:pPr/>
             <a:r>
               <a:rPr sz="1400"/>
-              <a:t>• Период 2015 – 2017 гг.</a:t>
+              <a:t>• Период: 2015 – 2017 годы</a:t>
             </a:r>
           </a:p>
           <a:p>
@@ -8471,7 +8517,7 @@
             <a:pPr/>
             <a:r>
               <a:rPr sz="1400"/>
-              <a:t>• Доля отмен — 37 %</a:t>
+              <a:t>• Доля отмен в данных — 37 %</a:t>
             </a:r>
           </a:p>
         </p:txBody>
@@ -8528,7 +8574,11 @@
             <p:ph type="title"/>
           </p:nvPr>
         </p:nvSpPr>
-        <p:spPr/>
+        <p:spPr>
+          <a:xfrm>
+            <a:ext cx="8500000" cy="0"/>
+          </a:xfrm>
+        </p:spPr>
         <p:txBody>
           <a:bodyPr/>
           <a:lstStyle/>
@@ -8564,7 +8614,7 @@
           <a:p>
             <a:r>
               <a:rPr sz="1400" b="0"/>
-              <a:t>Без чистки модель ловит мусор и утечку</a:t>
+              <a:t>Без чистки модель ловит шум и утечку целевой переменной</a:t>
             </a:r>
           </a:p>
         </p:txBody>
@@ -8594,21 +8644,21 @@
             <a:pPr/>
             <a:r>
               <a:rPr sz="1300"/>
-              <a:t>• Пропуски:</a:t>
+              <a:t>• Пропуски в колонках:</a:t>
             </a:r>
           </a:p>
           <a:p>
             <a:pPr/>
             <a:r>
               <a:rPr sz="1300"/>
-              <a:t>   страна клиента — 488 пустых → заменили на «неизвестно»</a:t>
+              <a:t>   страна клиента — 488 пустых → заменили на «неизвестно»;</a:t>
             </a:r>
           </a:p>
           <a:p>
             <a:pPr/>
             <a:r>
               <a:rPr sz="1300"/>
-              <a:t>   агентство — 16 340 пустых → заменили на «нет агентства»</a:t>
+              <a:t>   агентство — 16 340 пустых → заменили на «нет агентства»;</a:t>
             </a:r>
           </a:p>
           <a:p>
@@ -8622,7 +8672,7 @@
             <a:pPr/>
             <a:r>
               <a:rPr sz="1300"/>
-              <a:t>      превратили в бинарный признак «бронь от компании»</a:t>
+              <a:t>      превратили в бинарный признак «бронь от компании».</a:t>
             </a:r>
           </a:p>
           <a:p>
@@ -8643,14 +8693,21 @@
             <a:pPr/>
             <a:r>
               <a:rPr sz="1300"/>
-              <a:t>   были значения от −6 € до 5 400 € (а обычно около 100 €)</a:t>
+              <a:t>   встречались значения от −6 € до 5 400 €</a:t>
             </a:r>
           </a:p>
           <a:p>
             <a:pPr/>
             <a:r>
               <a:rPr sz="1300"/>
-              <a:t>   убрали записи с отрицательной ценой и аномально высокой</a:t>
+              <a:t>   (нормальный диапазон — около 100 €);</a:t>
+            </a:r>
+          </a:p>
+          <a:p>
+            <a:pPr/>
+            <a:r>
+              <a:rPr sz="1300"/>
+              <a:t>   убрали отрицательные и аномально высокие.</a:t>
             </a:r>
           </a:p>
           <a:p>
@@ -8664,14 +8721,14 @@
             <a:pPr/>
             <a:r>
               <a:rPr sz="1300"/>
-              <a:t>• Дубли: около 32 тысяч одинаковых строк → удалили</a:t>
+              <a:t>• Дубли: около 32 тысяч одинаковых строк — удалили.</a:t>
             </a:r>
           </a:p>
           <a:p>
             <a:pPr/>
             <a:r>
               <a:rPr sz="1300"/>
-              <a:t>• Брони с 0 гостей: удалили</a:t>
+              <a:t>• Брони с нулевым числом гостей — удалили.</a:t>
             </a:r>
           </a:p>
           <a:p>
@@ -8699,7 +8756,7 @@
             <a:pPr/>
             <a:r>
               <a:rPr sz="1300"/>
-              <a:t>   это прямой ответ. Удалили до обучения.</a:t>
+              <a:t>   это прямой ответ, удалили их до обучения.</a:t>
             </a:r>
           </a:p>
         </p:txBody>
@@ -8732,7 +8789,11 @@
             <p:ph type="title"/>
           </p:nvPr>
         </p:nvSpPr>
-        <p:spPr/>
+        <p:spPr>
+          <a:xfrm>
+            <a:ext cx="8500000" cy="0"/>
+          </a:xfrm>
+        </p:spPr>
         <p:txBody>
           <a:bodyPr/>
           <a:lstStyle/>
@@ -8768,70 +8829,84 @@
           <a:p>
             <a:pPr/>
             <a:r>
-              <a:rPr sz="1400"/>
-              <a:t>• У отменивших медианный</a:t>
-            </a:r>
-          </a:p>
-          <a:p>
-            <a:pPr/>
-            <a:r>
-              <a:rPr sz="1400"/>
-              <a:t>   срок до заезда почти в 2 раза</a:t>
-            </a:r>
-          </a:p>
-          <a:p>
-            <a:pPr/>
-            <a:r>
-              <a:rPr sz="1400"/>
-              <a:t>   больше, чем у доехавших</a:t>
-            </a:r>
-          </a:p>
-          <a:p>
-            <a:pPr/>
-            <a:r>
-              <a:rPr sz="1400"/>
+              <a:rPr sz="1300"/>
+              <a:t>• Чем дольше клиент ждёт</a:t>
+            </a:r>
+          </a:p>
+          <a:p>
+            <a:pPr/>
+            <a:r>
+              <a:rPr sz="1300"/>
+              <a:t>   до заезда, тем чаще отменяет</a:t>
+            </a:r>
+          </a:p>
+          <a:p>
+            <a:pPr/>
+            <a:r>
+              <a:rPr sz="1300"/>
               <a:t/>
             </a:r>
           </a:p>
           <a:p>
             <a:pPr/>
             <a:r>
-              <a:rPr sz="1400"/>
-              <a:t>• Логика простая:</a:t>
-            </a:r>
-          </a:p>
-          <a:p>
-            <a:pPr/>
-            <a:r>
-              <a:rPr sz="1400"/>
-              <a:t>   чем раньше человек бронирует,</a:t>
-            </a:r>
-          </a:p>
-          <a:p>
-            <a:pPr/>
-            <a:r>
-              <a:rPr sz="1400"/>
-              <a:t>   тем больше шансов передумать</a:t>
-            </a:r>
-          </a:p>
-          <a:p>
-            <a:pPr/>
-            <a:r>
-              <a:rPr sz="1400"/>
+              <a:rPr sz="1300"/>
+              <a:t>• Брони, оформленные за неделю</a:t>
+            </a:r>
+          </a:p>
+          <a:p>
+            <a:pPr/>
+            <a:r>
+              <a:rPr sz="1300"/>
+              <a:t>   до заезда, отменяют примерно</a:t>
+            </a:r>
+          </a:p>
+          <a:p>
+            <a:pPr/>
+            <a:r>
+              <a:rPr sz="1300"/>
+              <a:t>   в 10 % случаев</a:t>
+            </a:r>
+          </a:p>
+          <a:p>
+            <a:pPr/>
+            <a:r>
+              <a:rPr sz="1300"/>
               <a:t/>
             </a:r>
           </a:p>
           <a:p>
             <a:pPr/>
             <a:r>
-              <a:rPr sz="1400"/>
+              <a:rPr sz="1300"/>
+              <a:t>• Брони за 4–6 месяцев —</a:t>
+            </a:r>
+          </a:p>
+          <a:p>
+            <a:pPr/>
+            <a:r>
+              <a:rPr sz="1300"/>
+              <a:t>   отменяют почти в половине</a:t>
+            </a:r>
+          </a:p>
+          <a:p>
+            <a:pPr/>
+            <a:r>
+              <a:rPr sz="1300"/>
+              <a:t/>
+            </a:r>
+          </a:p>
+          <a:p>
+            <a:pPr/>
+            <a:r>
+              <a:rPr sz="1300"/>
               <a:t>• Это самый сильный</a:t>
             </a:r>
           </a:p>
           <a:p>
             <a:pPr/>
             <a:r>
-              <a:rPr sz="1400"/>
+              <a:rPr sz="1300"/>
               <a:t>   отдельный признак в данных</a:t>
             </a:r>
           </a:p>
@@ -8889,7 +8964,11 @@
             <p:ph type="title"/>
           </p:nvPr>
         </p:nvSpPr>
-        <p:spPr/>
+        <p:spPr>
+          <a:xfrm>
+            <a:ext cx="8500000" cy="0"/>
+          </a:xfrm>
+        </p:spPr>
         <p:txBody>
           <a:bodyPr/>
           <a:lstStyle/>
@@ -8926,28 +9005,28 @@
             <a:pPr/>
             <a:r>
               <a:rPr sz="1200"/>
-              <a:t>• «Невозвратный» депозит:</a:t>
+              <a:t>• Невозвратный депозит —</a:t>
             </a:r>
           </a:p>
           <a:p>
             <a:pPr/>
             <a:r>
               <a:rPr sz="1200"/>
-              <a:t>   почти всегда отменяют.</a:t>
+              <a:t>   почти всегда заканчивается</a:t>
             </a:r>
           </a:p>
           <a:p>
             <a:pPr/>
             <a:r>
               <a:rPr sz="1200"/>
-              <a:t>   Особенность датасета,</a:t>
+              <a:t>   отменой. Особенность датасета,</a:t>
             </a:r>
           </a:p>
           <a:p>
             <a:pPr/>
             <a:r>
               <a:rPr sz="1200"/>
-              <a:t>   описана в оригинальной статье.</a:t>
+              <a:t>   об этом пишут и авторы статьи.</a:t>
             </a:r>
           </a:p>
           <a:p>
@@ -8961,7 +9040,7 @@
             <a:pPr/>
             <a:r>
               <a:rPr sz="1200"/>
-              <a:t>• Португальцы (PRT)</a:t>
+              <a:t>• Клиенты из Португалии</a:t>
             </a:r>
           </a:p>
           <a:p>
@@ -8982,21 +9061,21 @@
             <a:pPr/>
             <a:r>
               <a:rPr sz="1200"/>
-              <a:t>• Логично: отели в Португалии,</a:t>
+              <a:t>• Логично: отели находятся</a:t>
             </a:r>
           </a:p>
           <a:p>
             <a:pPr/>
             <a:r>
               <a:rPr sz="1200"/>
-              <a:t>   местные жители бронируют</a:t>
+              <a:t>   в Португалии, местные</a:t>
             </a:r>
           </a:p>
           <a:p>
             <a:pPr/>
             <a:r>
               <a:rPr sz="1200"/>
-              <a:t>   без особых обязательств.</a:t>
+              <a:t>   бронируют «на всякий случай».</a:t>
             </a:r>
           </a:p>
         </p:txBody>
@@ -9077,7 +9156,11 @@
             <p:ph type="title"/>
           </p:nvPr>
         </p:nvSpPr>
-        <p:spPr/>
+        <p:spPr>
+          <a:xfrm>
+            <a:ext cx="8500000" cy="0"/>
+          </a:xfrm>
+        </p:spPr>
         <p:txBody>
           <a:bodyPr/>
           <a:lstStyle/>
@@ -9113,70 +9196,77 @@
           <a:p>
             <a:pPr/>
             <a:r>
-              <a:rPr sz="1400"/>
-              <a:t>• Летом доля отмен выше</a:t>
-            </a:r>
-          </a:p>
-          <a:p>
-            <a:pPr/>
-            <a:r>
-              <a:rPr sz="1400"/>
+              <a:rPr sz="1300"/>
+              <a:t>• Летом доля отмен заметно выше,</a:t>
+            </a:r>
+          </a:p>
+          <a:p>
+            <a:pPr/>
+            <a:r>
+              <a:rPr sz="1300"/>
+              <a:t>   зимой ниже</a:t>
+            </a:r>
+          </a:p>
+          <a:p>
+            <a:pPr/>
+            <a:r>
+              <a:rPr sz="1300"/>
               <a:t/>
             </a:r>
           </a:p>
           <a:p>
             <a:pPr/>
             <a:r>
-              <a:rPr sz="1400"/>
+              <a:rPr sz="1300"/>
               <a:t>• Январь – апрель — самые</a:t>
             </a:r>
           </a:p>
           <a:p>
             <a:pPr/>
             <a:r>
-              <a:rPr sz="1400"/>
+              <a:rPr sz="1300"/>
               <a:t>   спокойные месяцы</a:t>
             </a:r>
           </a:p>
           <a:p>
             <a:pPr/>
             <a:r>
-              <a:rPr sz="1400"/>
+              <a:rPr sz="1300"/>
               <a:t/>
             </a:r>
           </a:p>
           <a:p>
             <a:pPr/>
             <a:r>
-              <a:rPr sz="1400"/>
-              <a:t>• Из месяца сделали три</a:t>
-            </a:r>
-          </a:p>
-          <a:p>
-            <a:pPr/>
-            <a:r>
-              <a:rPr sz="1400"/>
-              <a:t>   признака для модели:</a:t>
-            </a:r>
-          </a:p>
-          <a:p>
-            <a:pPr/>
-            <a:r>
-              <a:rPr sz="1400"/>
+              <a:rPr sz="1300"/>
+              <a:t>• Из даты заезда сделали три</a:t>
+            </a:r>
+          </a:p>
+          <a:p>
+            <a:pPr/>
+            <a:r>
+              <a:rPr sz="1300"/>
+              <a:t>   полезных признака:</a:t>
+            </a:r>
+          </a:p>
+          <a:p>
+            <a:pPr/>
+            <a:r>
+              <a:rPr sz="1300"/>
               <a:t>   – номер месяца</a:t>
             </a:r>
           </a:p>
           <a:p>
             <a:pPr/>
             <a:r>
-              <a:rPr sz="1400"/>
+              <a:rPr sz="1300"/>
               <a:t>   – время года</a:t>
             </a:r>
           </a:p>
           <a:p>
             <a:pPr/>
             <a:r>
-              <a:rPr sz="1400"/>
+              <a:rPr sz="1300"/>
               <a:t>   – день недели заезда</a:t>
             </a:r>
           </a:p>
@@ -9234,7 +9324,11 @@
             <p:ph type="title"/>
           </p:nvPr>
         </p:nvSpPr>
-        <p:spPr/>
+        <p:spPr>
+          <a:xfrm>
+            <a:ext cx="8500000" cy="0"/>
+          </a:xfrm>
+        </p:spPr>
         <p:txBody>
           <a:bodyPr/>
           <a:lstStyle/>
@@ -9363,35 +9457,35 @@
             <a:pPr/>
             <a:r>
               <a:rPr sz="1200"/>
-              <a:t>      one-hot кодирование для линейных моделей,</a:t>
+              <a:t>      двоичное кодирование (one-hot) для линейных моделей,</a:t>
             </a:r>
           </a:p>
           <a:p>
             <a:pPr/>
             <a:r>
               <a:rPr sz="1200"/>
-              <a:t>      порядковое кодирование для деревьев и бустинга.</a:t>
+              <a:t>      порядковое кодирование для деревьев и бустинга;</a:t>
             </a:r>
           </a:p>
           <a:p>
             <a:pPr/>
             <a:r>
               <a:rPr sz="1200"/>
-              <a:t>   страна (около 175 значений) — целевое кодирование</a:t>
+              <a:t>   страна (около 175 значений) — целевое кодирование:</a:t>
             </a:r>
           </a:p>
           <a:p>
             <a:pPr/>
             <a:r>
               <a:rPr sz="1200"/>
-              <a:t>      (значение признака = средняя доля отмен по стране,</a:t>
+              <a:t>      значение признака = средняя доля отмен по стране,</a:t>
             </a:r>
           </a:p>
           <a:p>
             <a:pPr/>
             <a:r>
               <a:rPr sz="1200"/>
-              <a:t>      считается без утечки — отдельно для каждого фолда).</a:t>
+              <a:t>      считается отдельно для каждого фолда (без утечки).</a:t>
             </a:r>
           </a:p>
           <a:p>
@@ -9405,7 +9499,7 @@
             <a:pPr/>
             <a:r>
               <a:rPr sz="1200"/>
-              <a:t>• Разбиение: 80 % обучение / 20 % тест, со стратификацией.</a:t>
+              <a:t>• Разбиение: 80 % обучение / 20 % тест, со стратификацией по цели.</a:t>
             </a:r>
           </a:p>
         </p:txBody>
@@ -9438,7 +9532,11 @@
             <p:ph type="title"/>
           </p:nvPr>
         </p:nvSpPr>
-        <p:spPr/>
+        <p:spPr>
+          <a:xfrm>
+            <a:ext cx="8500000" cy="0"/>
+          </a:xfrm>
+        </p:spPr>
         <p:txBody>
           <a:bodyPr/>
           <a:lstStyle/>
@@ -9475,14 +9573,21 @@
             <a:pPr/>
             <a:r>
               <a:rPr sz="1200"/>
-              <a:t>5-фолдовая стратифицированная</a:t>
+              <a:t>Метрика: ROC-AUC по</a:t>
             </a:r>
           </a:p>
           <a:p>
             <a:pPr/>
             <a:r>
               <a:rPr sz="1200"/>
-              <a:t>кросс-валидация</a:t>
+              <a:t>5-фолдовой стратифицированной</a:t>
+            </a:r>
+          </a:p>
+          <a:p>
+            <a:pPr/>
+            <a:r>
+              <a:rPr sz="1200"/>
+              <a:t>кросс-валидации.</a:t>
             </a:r>
           </a:p>
           <a:p>
@@ -9545,14 +9650,14 @@
             <a:pPr/>
             <a:r>
               <a:rPr sz="1200"/>
-              <a:t>Разброс по фолдам ≈ 0.002,</a:t>
+              <a:t>Разброс по фолдам ≈ 0.002 —</a:t>
             </a:r>
           </a:p>
           <a:p>
             <a:pPr/>
             <a:r>
               <a:rPr sz="1200"/>
-              <a:t>результаты устойчивые</a:t>
+              <a:t>результаты устойчивые.</a:t>
             </a:r>
           </a:p>
         </p:txBody>

</xml_diff>

<commit_message>
fix slide titles: red color, top-anchored, no overflow
</commit_message>
<xml_diff>
--- a/docs/presentation.pptx
+++ b/docs/presentation.pptx
@@ -7291,25 +7291,49 @@
             <p:ph type="title"/>
           </p:nvPr>
         </p:nvSpPr>
-        <p:spPr>
-          <a:xfrm>
-            <a:ext cx="8500000" cy="0"/>
-          </a:xfrm>
-        </p:spPr>
+        <p:spPr/>
         <p:txBody>
           <a:bodyPr/>
           <a:lstStyle/>
-          <a:p>
-            <a:r>
-              <a:rPr sz="2200" b="1"/>
-              <a:t>Финальная модель — градиентный бустинг</a:t>
-            </a:r>
-          </a:p>
+          <a:p/>
         </p:txBody>
       </p:sp>
       <p:sp>
         <p:nvSpPr>
           <p:cNvPr id="3" name="TextBox 2"/>
+          <p:cNvSpPr txBox="1"/>
+          <p:nvPr/>
+        </p:nvSpPr>
+        <p:spPr>
+          <a:xfrm>
+            <a:off x="323528" y="220000"/>
+            <a:ext cx="8500000" cy="550000"/>
+          </a:xfrm>
+          <a:prstGeom prst="rect">
+            <a:avLst/>
+          </a:prstGeom>
+          <a:noFill/>
+        </p:spPr>
+        <p:txBody>
+          <a:bodyPr wrap="none">
+            <a:spAutoFit/>
+          </a:bodyPr>
+          <a:lstStyle/>
+          <a:p>
+            <a:r>
+              <a:rPr sz="2200" b="1">
+                <a:solidFill>
+                  <a:srgbClr val="953734"/>
+                </a:solidFill>
+              </a:rPr>
+              <a:t>Финальная модель — градиентный бустинг</a:t>
+            </a:r>
+          </a:p>
+        </p:txBody>
+      </p:sp>
+      <p:sp>
+        <p:nvSpPr>
+          <p:cNvPr id="4" name="TextBox 3"/>
           <p:cNvSpPr txBox="1"/>
           <p:nvPr/>
         </p:nvSpPr>
@@ -7444,7 +7468,7 @@
       </p:sp>
       <p:pic>
         <p:nvPicPr>
-          <p:cNvPr id="4" name="Picture 3" descr="importance.png"/>
+          <p:cNvPr id="5" name="Picture 4" descr="importance.png"/>
           <p:cNvPicPr>
             <a:picLocks noChangeAspect="1"/>
           </p:cNvPicPr>
@@ -7494,25 +7518,49 @@
             <p:ph type="title"/>
           </p:nvPr>
         </p:nvSpPr>
-        <p:spPr>
-          <a:xfrm>
-            <a:ext cx="8500000" cy="0"/>
-          </a:xfrm>
-        </p:spPr>
+        <p:spPr/>
         <p:txBody>
           <a:bodyPr/>
           <a:lstStyle/>
-          <a:p>
-            <a:r>
-              <a:rPr sz="2200" b="1"/>
-              <a:t>Насколько можно верить вероятностям</a:t>
-            </a:r>
-          </a:p>
+          <a:p/>
         </p:txBody>
       </p:sp>
       <p:sp>
         <p:nvSpPr>
           <p:cNvPr id="3" name="TextBox 2"/>
+          <p:cNvSpPr txBox="1"/>
+          <p:nvPr/>
+        </p:nvSpPr>
+        <p:spPr>
+          <a:xfrm>
+            <a:off x="323528" y="220000"/>
+            <a:ext cx="8500000" cy="550000"/>
+          </a:xfrm>
+          <a:prstGeom prst="rect">
+            <a:avLst/>
+          </a:prstGeom>
+          <a:noFill/>
+        </p:spPr>
+        <p:txBody>
+          <a:bodyPr wrap="none">
+            <a:spAutoFit/>
+          </a:bodyPr>
+          <a:lstStyle/>
+          <a:p>
+            <a:r>
+              <a:rPr sz="2200" b="1">
+                <a:solidFill>
+                  <a:srgbClr val="953734"/>
+                </a:solidFill>
+              </a:rPr>
+              <a:t>Насколько можно верить вероятностям</a:t>
+            </a:r>
+          </a:p>
+        </p:txBody>
+      </p:sp>
+      <p:sp>
+        <p:nvSpPr>
+          <p:cNvPr id="4" name="TextBox 3"/>
           <p:cNvSpPr txBox="1"/>
           <p:nvPr/>
         </p:nvSpPr>
@@ -7640,7 +7688,7 @@
       </p:sp>
       <p:pic>
         <p:nvPicPr>
-          <p:cNvPr id="4" name="Picture 3" descr="calibration.png"/>
+          <p:cNvPr id="5" name="Picture 4" descr="calibration.png"/>
           <p:cNvPicPr>
             <a:picLocks noChangeAspect="1"/>
           </p:cNvPicPr>
@@ -7690,25 +7738,49 @@
             <p:ph type="title"/>
           </p:nvPr>
         </p:nvSpPr>
-        <p:spPr>
-          <a:xfrm>
-            <a:ext cx="8500000" cy="0"/>
-          </a:xfrm>
-        </p:spPr>
+        <p:spPr/>
         <p:txBody>
           <a:bodyPr/>
           <a:lstStyle/>
-          <a:p>
-            <a:r>
-              <a:rPr sz="2200" b="1"/>
-              <a:t>Демонстрация приложения</a:t>
-            </a:r>
-          </a:p>
+          <a:p/>
         </p:txBody>
       </p:sp>
       <p:sp>
         <p:nvSpPr>
           <p:cNvPr id="3" name="TextBox 2"/>
+          <p:cNvSpPr txBox="1"/>
+          <p:nvPr/>
+        </p:nvSpPr>
+        <p:spPr>
+          <a:xfrm>
+            <a:off x="323528" y="220000"/>
+            <a:ext cx="8500000" cy="550000"/>
+          </a:xfrm>
+          <a:prstGeom prst="rect">
+            <a:avLst/>
+          </a:prstGeom>
+          <a:noFill/>
+        </p:spPr>
+        <p:txBody>
+          <a:bodyPr wrap="none">
+            <a:spAutoFit/>
+          </a:bodyPr>
+          <a:lstStyle/>
+          <a:p>
+            <a:r>
+              <a:rPr sz="2200" b="1">
+                <a:solidFill>
+                  <a:srgbClr val="953734"/>
+                </a:solidFill>
+              </a:rPr>
+              <a:t>Демонстрация приложения</a:t>
+            </a:r>
+          </a:p>
+        </p:txBody>
+      </p:sp>
+      <p:sp>
+        <p:nvSpPr>
+          <p:cNvPr id="4" name="TextBox 3"/>
           <p:cNvSpPr txBox="1"/>
           <p:nvPr/>
         </p:nvSpPr>
@@ -7737,7 +7809,7 @@
       </p:sp>
       <p:sp>
         <p:nvSpPr>
-          <p:cNvPr id="4" name="TextBox 3"/>
+          <p:cNvPr id="5" name="TextBox 4"/>
           <p:cNvSpPr txBox="1"/>
           <p:nvPr/>
         </p:nvSpPr>
@@ -7912,25 +7984,49 @@
             <p:ph type="title"/>
           </p:nvPr>
         </p:nvSpPr>
-        <p:spPr>
-          <a:xfrm>
-            <a:ext cx="8500000" cy="0"/>
-          </a:xfrm>
-        </p:spPr>
+        <p:spPr/>
         <p:txBody>
           <a:bodyPr/>
           <a:lstStyle/>
-          <a:p>
-            <a:r>
-              <a:rPr sz="2200" b="1"/>
-              <a:t>Как развернуть и чем рискуем</a:t>
-            </a:r>
-          </a:p>
+          <a:p/>
         </p:txBody>
       </p:sp>
       <p:sp>
         <p:nvSpPr>
           <p:cNvPr id="3" name="TextBox 2"/>
+          <p:cNvSpPr txBox="1"/>
+          <p:nvPr/>
+        </p:nvSpPr>
+        <p:spPr>
+          <a:xfrm>
+            <a:off x="323528" y="220000"/>
+            <a:ext cx="8500000" cy="550000"/>
+          </a:xfrm>
+          <a:prstGeom prst="rect">
+            <a:avLst/>
+          </a:prstGeom>
+          <a:noFill/>
+        </p:spPr>
+        <p:txBody>
+          <a:bodyPr wrap="none">
+            <a:spAutoFit/>
+          </a:bodyPr>
+          <a:lstStyle/>
+          <a:p>
+            <a:r>
+              <a:rPr sz="2200" b="1">
+                <a:solidFill>
+                  <a:srgbClr val="953734"/>
+                </a:solidFill>
+              </a:rPr>
+              <a:t>Как развернуть и чем рискуем</a:t>
+            </a:r>
+          </a:p>
+        </p:txBody>
+      </p:sp>
+      <p:sp>
+        <p:nvSpPr>
+          <p:cNvPr id="4" name="TextBox 3"/>
           <p:cNvSpPr txBox="1"/>
           <p:nvPr/>
         </p:nvSpPr>
@@ -7959,7 +8055,7 @@
       </p:sp>
       <p:sp>
         <p:nvSpPr>
-          <p:cNvPr id="4" name="TextBox 3"/>
+          <p:cNvPr id="5" name="TextBox 4"/>
           <p:cNvSpPr txBox="1"/>
           <p:nvPr/>
         </p:nvSpPr>
@@ -8124,12 +8220,7 @@
         <p:txBody>
           <a:bodyPr/>
           <a:lstStyle/>
-          <a:p>
-            <a:r>
-              <a:rPr sz="100"/>
-              <a:t/>
-            </a:r>
-          </a:p>
+          <a:p/>
         </p:txBody>
       </p:sp>
       <p:sp>
@@ -8146,12 +8237,7 @@
         <p:txBody>
           <a:bodyPr/>
           <a:lstStyle/>
-          <a:p>
-            <a:r>
-              <a:rPr sz="100"/>
-              <a:t/>
-            </a:r>
-          </a:p>
+          <a:p/>
         </p:txBody>
       </p:sp>
       <p:sp>
@@ -8162,8 +8248,8 @@
         </p:nvSpPr>
         <p:spPr>
           <a:xfrm>
-            <a:off x="0" y="1800000"/>
-            <a:ext cx="9144000" cy="1500000"/>
+            <a:off x="0" y="2000000"/>
+            <a:ext cx="9144000" cy="1200000"/>
           </a:xfrm>
           <a:prstGeom prst="rect">
             <a:avLst/>
@@ -8178,7 +8264,11 @@
           <a:p>
             <a:pPr algn="ctr"/>
             <a:r>
-              <a:rPr sz="5400" b="1"/>
+              <a:rPr sz="5400" b="1">
+                <a:solidFill>
+                  <a:srgbClr val="953734"/>
+                </a:solidFill>
+              </a:rPr>
               <a:t>Спасибо за внимание</a:t>
             </a:r>
           </a:p>
@@ -8212,25 +8302,49 @@
             <p:ph type="title"/>
           </p:nvPr>
         </p:nvSpPr>
-        <p:spPr>
-          <a:xfrm>
-            <a:ext cx="8500000" cy="0"/>
-          </a:xfrm>
-        </p:spPr>
+        <p:spPr/>
         <p:txBody>
           <a:bodyPr/>
           <a:lstStyle/>
-          <a:p>
-            <a:r>
-              <a:rPr sz="2200" b="1"/>
-              <a:t>Задача и зачем это нужно</a:t>
-            </a:r>
-          </a:p>
+          <a:p/>
         </p:txBody>
       </p:sp>
       <p:sp>
         <p:nvSpPr>
           <p:cNvPr id="3" name="TextBox 2"/>
+          <p:cNvSpPr txBox="1"/>
+          <p:nvPr/>
+        </p:nvSpPr>
+        <p:spPr>
+          <a:xfrm>
+            <a:off x="323528" y="220000"/>
+            <a:ext cx="8500000" cy="550000"/>
+          </a:xfrm>
+          <a:prstGeom prst="rect">
+            <a:avLst/>
+          </a:prstGeom>
+          <a:noFill/>
+        </p:spPr>
+        <p:txBody>
+          <a:bodyPr wrap="none">
+            <a:spAutoFit/>
+          </a:bodyPr>
+          <a:lstStyle/>
+          <a:p>
+            <a:r>
+              <a:rPr sz="2200" b="1">
+                <a:solidFill>
+                  <a:srgbClr val="953734"/>
+                </a:solidFill>
+              </a:rPr>
+              <a:t>Задача и зачем это нужно</a:t>
+            </a:r>
+          </a:p>
+        </p:txBody>
+      </p:sp>
+      <p:sp>
+        <p:nvSpPr>
+          <p:cNvPr id="4" name="TextBox 3"/>
           <p:cNvSpPr txBox="1"/>
           <p:nvPr/>
         </p:nvSpPr>
@@ -8259,7 +8373,7 @@
       </p:sp>
       <p:sp>
         <p:nvSpPr>
-          <p:cNvPr id="4" name="TextBox 3"/>
+          <p:cNvPr id="5" name="TextBox 4"/>
           <p:cNvSpPr txBox="1"/>
           <p:nvPr/>
         </p:nvSpPr>
@@ -8399,25 +8513,49 @@
             <p:ph type="title"/>
           </p:nvPr>
         </p:nvSpPr>
-        <p:spPr>
-          <a:xfrm>
-            <a:ext cx="8500000" cy="0"/>
-          </a:xfrm>
-        </p:spPr>
+        <p:spPr/>
         <p:txBody>
           <a:bodyPr/>
           <a:lstStyle/>
-          <a:p>
-            <a:r>
-              <a:rPr sz="2200" b="1"/>
-              <a:t>Данные</a:t>
-            </a:r>
-          </a:p>
+          <a:p/>
         </p:txBody>
       </p:sp>
       <p:sp>
         <p:nvSpPr>
           <p:cNvPr id="3" name="TextBox 2"/>
+          <p:cNvSpPr txBox="1"/>
+          <p:nvPr/>
+        </p:nvSpPr>
+        <p:spPr>
+          <a:xfrm>
+            <a:off x="323528" y="220000"/>
+            <a:ext cx="8500000" cy="550000"/>
+          </a:xfrm>
+          <a:prstGeom prst="rect">
+            <a:avLst/>
+          </a:prstGeom>
+          <a:noFill/>
+        </p:spPr>
+        <p:txBody>
+          <a:bodyPr wrap="none">
+            <a:spAutoFit/>
+          </a:bodyPr>
+          <a:lstStyle/>
+          <a:p>
+            <a:r>
+              <a:rPr sz="2200" b="1">
+                <a:solidFill>
+                  <a:srgbClr val="953734"/>
+                </a:solidFill>
+              </a:rPr>
+              <a:t>Данные</a:t>
+            </a:r>
+          </a:p>
+        </p:txBody>
+      </p:sp>
+      <p:sp>
+        <p:nvSpPr>
+          <p:cNvPr id="4" name="TextBox 3"/>
           <p:cNvSpPr txBox="1"/>
           <p:nvPr/>
         </p:nvSpPr>
@@ -8524,7 +8662,7 @@
       </p:sp>
       <p:pic>
         <p:nvPicPr>
-          <p:cNvPr id="4" name="Picture 3" descr="balance.png"/>
+          <p:cNvPr id="5" name="Picture 4" descr="balance.png"/>
           <p:cNvPicPr>
             <a:picLocks noChangeAspect="1"/>
           </p:cNvPicPr>
@@ -8574,25 +8712,49 @@
             <p:ph type="title"/>
           </p:nvPr>
         </p:nvSpPr>
-        <p:spPr>
-          <a:xfrm>
-            <a:ext cx="8500000" cy="0"/>
-          </a:xfrm>
-        </p:spPr>
+        <p:spPr/>
         <p:txBody>
           <a:bodyPr/>
           <a:lstStyle/>
-          <a:p>
-            <a:r>
-              <a:rPr sz="2200" b="1"/>
-              <a:t>Что почистили в данных</a:t>
-            </a:r>
-          </a:p>
+          <a:p/>
         </p:txBody>
       </p:sp>
       <p:sp>
         <p:nvSpPr>
           <p:cNvPr id="3" name="TextBox 2"/>
+          <p:cNvSpPr txBox="1"/>
+          <p:nvPr/>
+        </p:nvSpPr>
+        <p:spPr>
+          <a:xfrm>
+            <a:off x="323528" y="220000"/>
+            <a:ext cx="8500000" cy="550000"/>
+          </a:xfrm>
+          <a:prstGeom prst="rect">
+            <a:avLst/>
+          </a:prstGeom>
+          <a:noFill/>
+        </p:spPr>
+        <p:txBody>
+          <a:bodyPr wrap="none">
+            <a:spAutoFit/>
+          </a:bodyPr>
+          <a:lstStyle/>
+          <a:p>
+            <a:r>
+              <a:rPr sz="2200" b="1">
+                <a:solidFill>
+                  <a:srgbClr val="953734"/>
+                </a:solidFill>
+              </a:rPr>
+              <a:t>Что почистили в данных</a:t>
+            </a:r>
+          </a:p>
+        </p:txBody>
+      </p:sp>
+      <p:sp>
+        <p:nvSpPr>
+          <p:cNvPr id="4" name="TextBox 3"/>
           <p:cNvSpPr txBox="1"/>
           <p:nvPr/>
         </p:nvSpPr>
@@ -8621,7 +8783,7 @@
       </p:sp>
       <p:sp>
         <p:nvSpPr>
-          <p:cNvPr id="4" name="TextBox 3"/>
+          <p:cNvPr id="5" name="TextBox 4"/>
           <p:cNvSpPr txBox="1"/>
           <p:nvPr/>
         </p:nvSpPr>
@@ -8789,25 +8951,49 @@
             <p:ph type="title"/>
           </p:nvPr>
         </p:nvSpPr>
-        <p:spPr>
-          <a:xfrm>
-            <a:ext cx="8500000" cy="0"/>
-          </a:xfrm>
-        </p:spPr>
+        <p:spPr/>
         <p:txBody>
           <a:bodyPr/>
           <a:lstStyle/>
-          <a:p>
-            <a:r>
-              <a:rPr sz="2200" b="1"/>
-              <a:t>Главный сигнал: срок до заезда</a:t>
-            </a:r>
-          </a:p>
+          <a:p/>
         </p:txBody>
       </p:sp>
       <p:sp>
         <p:nvSpPr>
           <p:cNvPr id="3" name="TextBox 2"/>
+          <p:cNvSpPr txBox="1"/>
+          <p:nvPr/>
+        </p:nvSpPr>
+        <p:spPr>
+          <a:xfrm>
+            <a:off x="323528" y="220000"/>
+            <a:ext cx="8500000" cy="550000"/>
+          </a:xfrm>
+          <a:prstGeom prst="rect">
+            <a:avLst/>
+          </a:prstGeom>
+          <a:noFill/>
+        </p:spPr>
+        <p:txBody>
+          <a:bodyPr wrap="none">
+            <a:spAutoFit/>
+          </a:bodyPr>
+          <a:lstStyle/>
+          <a:p>
+            <a:r>
+              <a:rPr sz="2200" b="1">
+                <a:solidFill>
+                  <a:srgbClr val="953734"/>
+                </a:solidFill>
+              </a:rPr>
+              <a:t>Главный сигнал: срок до заезда</a:t>
+            </a:r>
+          </a:p>
+        </p:txBody>
+      </p:sp>
+      <p:sp>
+        <p:nvSpPr>
+          <p:cNvPr id="4" name="TextBox 3"/>
           <p:cNvSpPr txBox="1"/>
           <p:nvPr/>
         </p:nvSpPr>
@@ -8914,7 +9100,7 @@
       </p:sp>
       <p:pic>
         <p:nvPicPr>
-          <p:cNvPr id="4" name="Picture 3" descr="lead_time.png"/>
+          <p:cNvPr id="5" name="Picture 4" descr="lead_time.png"/>
           <p:cNvPicPr>
             <a:picLocks noChangeAspect="1"/>
           </p:cNvPicPr>
@@ -8964,25 +9150,49 @@
             <p:ph type="title"/>
           </p:nvPr>
         </p:nvSpPr>
-        <p:spPr>
-          <a:xfrm>
-            <a:ext cx="8500000" cy="0"/>
-          </a:xfrm>
-        </p:spPr>
+        <p:spPr/>
         <p:txBody>
           <a:bodyPr/>
           <a:lstStyle/>
-          <a:p>
-            <a:r>
-              <a:rPr sz="2200" b="1"/>
-              <a:t>Депозит и страна клиента</a:t>
-            </a:r>
-          </a:p>
+          <a:p/>
         </p:txBody>
       </p:sp>
       <p:sp>
         <p:nvSpPr>
           <p:cNvPr id="3" name="TextBox 2"/>
+          <p:cNvSpPr txBox="1"/>
+          <p:nvPr/>
+        </p:nvSpPr>
+        <p:spPr>
+          <a:xfrm>
+            <a:off x="323528" y="220000"/>
+            <a:ext cx="8500000" cy="550000"/>
+          </a:xfrm>
+          <a:prstGeom prst="rect">
+            <a:avLst/>
+          </a:prstGeom>
+          <a:noFill/>
+        </p:spPr>
+        <p:txBody>
+          <a:bodyPr wrap="none">
+            <a:spAutoFit/>
+          </a:bodyPr>
+          <a:lstStyle/>
+          <a:p>
+            <a:r>
+              <a:rPr sz="2200" b="1">
+                <a:solidFill>
+                  <a:srgbClr val="953734"/>
+                </a:solidFill>
+              </a:rPr>
+              <a:t>Депозит и страна клиента</a:t>
+            </a:r>
+          </a:p>
+        </p:txBody>
+      </p:sp>
+      <p:sp>
+        <p:nvSpPr>
+          <p:cNvPr id="4" name="TextBox 3"/>
           <p:cNvSpPr txBox="1"/>
           <p:nvPr/>
         </p:nvSpPr>
@@ -9082,7 +9292,7 @@
       </p:sp>
       <p:pic>
         <p:nvPicPr>
-          <p:cNvPr id="4" name="Picture 3" descr="deposit.png"/>
+          <p:cNvPr id="5" name="Picture 4" descr="deposit.png"/>
           <p:cNvPicPr>
             <a:picLocks noChangeAspect="1"/>
           </p:cNvPicPr>
@@ -9106,7 +9316,7 @@
       </p:pic>
       <p:pic>
         <p:nvPicPr>
-          <p:cNvPr id="5" name="Picture 4" descr="country.png"/>
+          <p:cNvPr id="6" name="Picture 5" descr="country.png"/>
           <p:cNvPicPr>
             <a:picLocks noChangeAspect="1"/>
           </p:cNvPicPr>
@@ -9156,25 +9366,49 @@
             <p:ph type="title"/>
           </p:nvPr>
         </p:nvSpPr>
-        <p:spPr>
-          <a:xfrm>
-            <a:ext cx="8500000" cy="0"/>
-          </a:xfrm>
-        </p:spPr>
+        <p:spPr/>
         <p:txBody>
           <a:bodyPr/>
           <a:lstStyle/>
-          <a:p>
-            <a:r>
-              <a:rPr sz="2200" b="1"/>
-              <a:t>Сезонность</a:t>
-            </a:r>
-          </a:p>
+          <a:p/>
         </p:txBody>
       </p:sp>
       <p:sp>
         <p:nvSpPr>
           <p:cNvPr id="3" name="TextBox 2"/>
+          <p:cNvSpPr txBox="1"/>
+          <p:nvPr/>
+        </p:nvSpPr>
+        <p:spPr>
+          <a:xfrm>
+            <a:off x="323528" y="220000"/>
+            <a:ext cx="8500000" cy="550000"/>
+          </a:xfrm>
+          <a:prstGeom prst="rect">
+            <a:avLst/>
+          </a:prstGeom>
+          <a:noFill/>
+        </p:spPr>
+        <p:txBody>
+          <a:bodyPr wrap="none">
+            <a:spAutoFit/>
+          </a:bodyPr>
+          <a:lstStyle/>
+          <a:p>
+            <a:r>
+              <a:rPr sz="2200" b="1">
+                <a:solidFill>
+                  <a:srgbClr val="953734"/>
+                </a:solidFill>
+              </a:rPr>
+              <a:t>Сезонность</a:t>
+            </a:r>
+          </a:p>
+        </p:txBody>
+      </p:sp>
+      <p:sp>
+        <p:nvSpPr>
+          <p:cNvPr id="4" name="TextBox 3"/>
           <p:cNvSpPr txBox="1"/>
           <p:nvPr/>
         </p:nvSpPr>
@@ -9274,7 +9508,7 @@
       </p:sp>
       <p:pic>
         <p:nvPicPr>
-          <p:cNvPr id="4" name="Picture 3" descr="season.png"/>
+          <p:cNvPr id="5" name="Picture 4" descr="season.png"/>
           <p:cNvPicPr>
             <a:picLocks noChangeAspect="1"/>
           </p:cNvPicPr>
@@ -9324,25 +9558,49 @@
             <p:ph type="title"/>
           </p:nvPr>
         </p:nvSpPr>
-        <p:spPr>
-          <a:xfrm>
-            <a:ext cx="8500000" cy="0"/>
-          </a:xfrm>
-        </p:spPr>
+        <p:spPr/>
         <p:txBody>
           <a:bodyPr/>
           <a:lstStyle/>
-          <a:p>
-            <a:r>
-              <a:rPr sz="2200" b="1"/>
-              <a:t>Подготовка данных и новые признаки</a:t>
-            </a:r>
-          </a:p>
+          <a:p/>
         </p:txBody>
       </p:sp>
       <p:sp>
         <p:nvSpPr>
           <p:cNvPr id="3" name="TextBox 2"/>
+          <p:cNvSpPr txBox="1"/>
+          <p:nvPr/>
+        </p:nvSpPr>
+        <p:spPr>
+          <a:xfrm>
+            <a:off x="323528" y="220000"/>
+            <a:ext cx="8500000" cy="550000"/>
+          </a:xfrm>
+          <a:prstGeom prst="rect">
+            <a:avLst/>
+          </a:prstGeom>
+          <a:noFill/>
+        </p:spPr>
+        <p:txBody>
+          <a:bodyPr wrap="none">
+            <a:spAutoFit/>
+          </a:bodyPr>
+          <a:lstStyle/>
+          <a:p>
+            <a:r>
+              <a:rPr sz="2200" b="1">
+                <a:solidFill>
+                  <a:srgbClr val="953734"/>
+                </a:solidFill>
+              </a:rPr>
+              <a:t>Подготовка данных и новые признаки</a:t>
+            </a:r>
+          </a:p>
+        </p:txBody>
+      </p:sp>
+      <p:sp>
+        <p:nvSpPr>
+          <p:cNvPr id="4" name="TextBox 3"/>
           <p:cNvSpPr txBox="1"/>
           <p:nvPr/>
         </p:nvSpPr>
@@ -9371,7 +9629,7 @@
       </p:sp>
       <p:sp>
         <p:nvSpPr>
-          <p:cNvPr id="4" name="TextBox 3"/>
+          <p:cNvPr id="5" name="TextBox 4"/>
           <p:cNvSpPr txBox="1"/>
           <p:nvPr/>
         </p:nvSpPr>
@@ -9532,25 +9790,49 @@
             <p:ph type="title"/>
           </p:nvPr>
         </p:nvSpPr>
-        <p:spPr>
-          <a:xfrm>
-            <a:ext cx="8500000" cy="0"/>
-          </a:xfrm>
-        </p:spPr>
+        <p:spPr/>
         <p:txBody>
           <a:bodyPr/>
           <a:lstStyle/>
-          <a:p>
-            <a:r>
-              <a:rPr sz="2200" b="1"/>
-              <a:t>Сравнение моделей</a:t>
-            </a:r>
-          </a:p>
+          <a:p/>
         </p:txBody>
       </p:sp>
       <p:sp>
         <p:nvSpPr>
           <p:cNvPr id="3" name="TextBox 2"/>
+          <p:cNvSpPr txBox="1"/>
+          <p:nvPr/>
+        </p:nvSpPr>
+        <p:spPr>
+          <a:xfrm>
+            <a:off x="323528" y="220000"/>
+            <a:ext cx="8500000" cy="550000"/>
+          </a:xfrm>
+          <a:prstGeom prst="rect">
+            <a:avLst/>
+          </a:prstGeom>
+          <a:noFill/>
+        </p:spPr>
+        <p:txBody>
+          <a:bodyPr wrap="none">
+            <a:spAutoFit/>
+          </a:bodyPr>
+          <a:lstStyle/>
+          <a:p>
+            <a:r>
+              <a:rPr sz="2200" b="1">
+                <a:solidFill>
+                  <a:srgbClr val="953734"/>
+                </a:solidFill>
+              </a:rPr>
+              <a:t>Сравнение моделей</a:t>
+            </a:r>
+          </a:p>
+        </p:txBody>
+      </p:sp>
+      <p:sp>
+        <p:nvSpPr>
+          <p:cNvPr id="4" name="TextBox 3"/>
           <p:cNvSpPr txBox="1"/>
           <p:nvPr/>
         </p:nvSpPr>
@@ -9664,7 +9946,7 @@
       </p:sp>
       <p:pic>
         <p:nvPicPr>
-          <p:cNvPr id="4" name="Picture 3" descr="models.png"/>
+          <p:cNvPr id="5" name="Picture 4" descr="models.png"/>
           <p:cNvPicPr>
             <a:picLocks noChangeAspect="1"/>
           </p:cNvPicPr>

</xml_diff>

<commit_message>
calibration chart: use uniform bins + add proba histogram
</commit_message>
<xml_diff>
--- a/docs/presentation.pptx
+++ b/docs/presentation.pptx
@@ -7582,106 +7582,148 @@
           <a:p>
             <a:pPr/>
             <a:r>
-              <a:rPr sz="1100"/>
-              <a:t>Идея калибровки:</a:t>
-            </a:r>
-          </a:p>
-          <a:p>
-            <a:pPr/>
-            <a:r>
-              <a:rPr sz="1100"/>
-              <a:t>если модель говорит «70 % шанс»,</a:t>
-            </a:r>
-          </a:p>
-          <a:p>
-            <a:pPr/>
-            <a:r>
-              <a:rPr sz="1100"/>
-              <a:t>то реально из таких броней</a:t>
-            </a:r>
-          </a:p>
-          <a:p>
-            <a:pPr/>
-            <a:r>
-              <a:rPr sz="1100"/>
-              <a:t>должно отмениться 70 %.</a:t>
-            </a:r>
-          </a:p>
-          <a:p>
-            <a:pPr/>
-            <a:r>
-              <a:rPr sz="1100"/>
+              <a:rPr sz="1050"/>
+              <a:t>Идея калибровки: если модель</a:t>
+            </a:r>
+          </a:p>
+          <a:p>
+            <a:pPr/>
+            <a:r>
+              <a:rPr sz="1050"/>
+              <a:t>говорит «70 % шанс», то реально</a:t>
+            </a:r>
+          </a:p>
+          <a:p>
+            <a:pPr/>
+            <a:r>
+              <a:rPr sz="1050"/>
+              <a:t>из таких броней должно</a:t>
+            </a:r>
+          </a:p>
+          <a:p>
+            <a:pPr/>
+            <a:r>
+              <a:rPr sz="1050"/>
+              <a:t>отмениться 70 %.</a:t>
+            </a:r>
+          </a:p>
+          <a:p>
+            <a:pPr/>
+            <a:r>
+              <a:rPr sz="1050"/>
               <a:t/>
             </a:r>
           </a:p>
           <a:p>
             <a:pPr/>
             <a:r>
-              <a:rPr sz="1100"/>
-              <a:t>• Логистическая регрессия —</a:t>
-            </a:r>
-          </a:p>
-          <a:p>
-            <a:pPr/>
-            <a:r>
-              <a:rPr sz="1100"/>
-              <a:t>   почти идеально</a:t>
-            </a:r>
-          </a:p>
-          <a:p>
-            <a:pPr/>
-            <a:r>
-              <a:rPr sz="1100"/>
+              <a:rPr sz="1050"/>
+              <a:t>Замер на тестовых данных</a:t>
+            </a:r>
+          </a:p>
+          <a:p>
+            <a:pPr/>
+            <a:r>
+              <a:rPr sz="1050"/>
+              <a:t>(модели их не видели).</a:t>
+            </a:r>
+          </a:p>
+          <a:p>
+            <a:pPr/>
+            <a:r>
+              <a:rPr sz="1050"/>
               <a:t/>
             </a:r>
           </a:p>
           <a:p>
             <a:pPr/>
             <a:r>
-              <a:rPr sz="1100"/>
-              <a:t>• Случайный лес — задирает</a:t>
-            </a:r>
-          </a:p>
-          <a:p>
-            <a:pPr/>
-            <a:r>
-              <a:rPr sz="1100"/>
-              <a:t>   уверенность: предсказал 0.9,</a:t>
-            </a:r>
-          </a:p>
-          <a:p>
-            <a:pPr/>
-            <a:r>
-              <a:rPr sz="1100"/>
-              <a:t>   а отменили только 70 %</a:t>
-            </a:r>
-          </a:p>
-          <a:p>
-            <a:pPr/>
-            <a:r>
-              <a:rPr sz="1100"/>
+              <a:rPr sz="1050"/>
+              <a:t>• Логистическая регрессия:</a:t>
+            </a:r>
+          </a:p>
+          <a:p>
+            <a:pPr/>
+            <a:r>
+              <a:rPr sz="1050"/>
+              <a:t>   почти на диагонали,</a:t>
+            </a:r>
+          </a:p>
+          <a:p>
+            <a:pPr/>
+            <a:r>
+              <a:rPr sz="1050"/>
+              <a:t>   отклонение &lt; 2 %.</a:t>
+            </a:r>
+          </a:p>
+          <a:p>
+            <a:pPr/>
+            <a:r>
+              <a:rPr sz="1050"/>
               <a:t/>
             </a:r>
           </a:p>
           <a:p>
             <a:pPr/>
             <a:r>
-              <a:rPr sz="1100"/>
-              <a:t>• Градиентный бустинг — близко</a:t>
-            </a:r>
-          </a:p>
-          <a:p>
-            <a:pPr/>
-            <a:r>
-              <a:rPr sz="1100"/>
-              <a:t>   к идеалу, чуть переоценивает</a:t>
-            </a:r>
-          </a:p>
-          <a:p>
-            <a:pPr/>
-            <a:r>
-              <a:rPr sz="1100"/>
-              <a:t>   высокие вероятности</a:t>
+              <a:rPr sz="1050"/>
+              <a:t>• Случайный лес: задирает</a:t>
+            </a:r>
+          </a:p>
+          <a:p>
+            <a:pPr/>
+            <a:r>
+              <a:rPr sz="1050"/>
+              <a:t>   уверенность в средних бинах,</a:t>
+            </a:r>
+          </a:p>
+          <a:p>
+            <a:pPr/>
+            <a:r>
+              <a:rPr sz="1050"/>
+              <a:t>   отклонение до 8 %.</a:t>
+            </a:r>
+          </a:p>
+          <a:p>
+            <a:pPr/>
+            <a:r>
+              <a:rPr sz="1050"/>
+              <a:t/>
+            </a:r>
+          </a:p>
+          <a:p>
+            <a:pPr/>
+            <a:r>
+              <a:rPr sz="1050"/>
+              <a:t>• Градиентный бустинг:</a:t>
+            </a:r>
+          </a:p>
+          <a:p>
+            <a:pPr/>
+            <a:r>
+              <a:rPr sz="1050"/>
+              <a:t>   аналогично, до 7 %.</a:t>
+            </a:r>
+          </a:p>
+          <a:p>
+            <a:pPr/>
+            <a:r>
+              <a:rPr sz="1050"/>
+              <a:t/>
+            </a:r>
+          </a:p>
+          <a:p>
+            <a:pPr/>
+            <a:r>
+              <a:rPr sz="1050"/>
+              <a:t>Снизу — как распределены</a:t>
+            </a:r>
+          </a:p>
+          <a:p>
+            <a:pPr/>
+            <a:r>
+              <a:rPr sz="1050"/>
+              <a:t>предсказания (лог. шкала).</a:t>
             </a:r>
           </a:p>
         </p:txBody>
@@ -7703,7 +7745,7 @@
         <p:spPr>
           <a:xfrm>
             <a:off x="4700000" y="1059582"/>
-            <a:ext cx="4200000" cy="2800000"/>
+            <a:ext cx="4200000" cy="3500000"/>
           </a:xfrm>
           <a:prstGeom prst="rect">
             <a:avLst/>

</xml_diff>

<commit_message>
calibration: residual plot instead of reliability
</commit_message>
<xml_diff>
--- a/docs/presentation.pptx
+++ b/docs/presentation.pptx
@@ -7618,14 +7618,21 @@
             <a:pPr/>
             <a:r>
               <a:rPr sz="1050"/>
-              <a:t>Замер на тестовых данных</a:t>
+              <a:t>На графике справа — насколько</a:t>
             </a:r>
           </a:p>
           <a:p>
             <a:pPr/>
             <a:r>
               <a:rPr sz="1050"/>
-              <a:t>(модели их не видели).</a:t>
+              <a:t>модель промахивается.</a:t>
+            </a:r>
+          </a:p>
+          <a:p>
+            <a:pPr/>
+            <a:r>
+              <a:rPr sz="1050"/>
+              <a:t>Ноль — идеальная калибровка.</a:t>
             </a:r>
           </a:p>
           <a:p>
@@ -7646,14 +7653,7 @@
             <a:pPr/>
             <a:r>
               <a:rPr sz="1050"/>
-              <a:t>   почти на диагонали,</a:t>
-            </a:r>
-          </a:p>
-          <a:p>
-            <a:pPr/>
-            <a:r>
-              <a:rPr sz="1050"/>
-              <a:t>   отклонение &lt; 2 %.</a:t>
+              <a:t>   почти на нуле, промах &lt; 2 %.</a:t>
             </a:r>
           </a:p>
           <a:p>
@@ -7667,21 +7667,21 @@
             <a:pPr/>
             <a:r>
               <a:rPr sz="1050"/>
-              <a:t>• Случайный лес: задирает</a:t>
+              <a:t>• Случайный лес: уходит ниже</a:t>
             </a:r>
           </a:p>
           <a:p>
             <a:pPr/>
             <a:r>
               <a:rPr sz="1050"/>
-              <a:t>   уверенность в средних бинах,</a:t>
+              <a:t>   нуля в средней зоне —</a:t>
             </a:r>
           </a:p>
           <a:p>
             <a:pPr/>
             <a:r>
               <a:rPr sz="1050"/>
-              <a:t>   отклонение до 8 %.</a:t>
+              <a:t>   задирает уверенность до 8 %.</a:t>
             </a:r>
           </a:p>
           <a:p>
@@ -7695,14 +7695,14 @@
             <a:pPr/>
             <a:r>
               <a:rPr sz="1050"/>
-              <a:t>• Градиентный бустинг:</a:t>
+              <a:t>• Градиентный бустинг —</a:t>
             </a:r>
           </a:p>
           <a:p>
             <a:pPr/>
             <a:r>
               <a:rPr sz="1050"/>
-              <a:t>   аналогично, до 7 %.</a:t>
+              <a:t>   похожая картина, до 7 %.</a:t>
             </a:r>
           </a:p>
           <a:p>
@@ -7716,14 +7716,21 @@
             <a:pPr/>
             <a:r>
               <a:rPr sz="1050"/>
-              <a:t>Снизу — как распределены</a:t>
+              <a:t>Снизу видно, что большинство</a:t>
             </a:r>
           </a:p>
           <a:p>
             <a:pPr/>
             <a:r>
               <a:rPr sz="1050"/>
-              <a:t>предсказания (лог. шкала).</a:t>
+              <a:t>броней получают вероятность</a:t>
+            </a:r>
+          </a:p>
+          <a:p>
+            <a:pPr/>
+            <a:r>
+              <a:rPr sz="1050"/>
+              <a:t>меньше 0.3 (лог. шкала).</a:t>
             </a:r>
           </a:p>
         </p:txBody>
@@ -7744,8 +7751,8 @@
         </p:blipFill>
         <p:spPr>
           <a:xfrm>
-            <a:off x="4700000" y="1059582"/>
-            <a:ext cx="4200000" cy="3500000"/>
+            <a:off x="4700000" y="900000"/>
+            <a:ext cx="4200000" cy="3800000"/>
           </a:xfrm>
           <a:prstGeom prst="rect">
             <a:avLst/>

</xml_diff>

<commit_message>
sync feature importance wording between slides and report
</commit_message>
<xml_diff>
--- a/docs/presentation.pptx
+++ b/docs/presentation.pptx
@@ -7356,14 +7356,21 @@
             <a:pPr/>
             <a:r>
               <a:rPr sz="1100"/>
-              <a:t>HistGradientBoosting из</a:t>
+              <a:t>Качество на тесте:</a:t>
             </a:r>
           </a:p>
           <a:p>
             <a:pPr/>
             <a:r>
               <a:rPr sz="1100"/>
-              <a:t>библиотеки scikit-learn</a:t>
+              <a:t>   ROC-AUC = 0.917</a:t>
+            </a:r>
+          </a:p>
+          <a:p>
+            <a:pPr/>
+            <a:r>
+              <a:rPr sz="1100"/>
+              <a:t>   F1-мера = 0.77, полнота 0.67</a:t>
             </a:r>
           </a:p>
           <a:p>
@@ -7377,28 +7384,14 @@
             <a:pPr/>
             <a:r>
               <a:rPr sz="1100"/>
-              <a:t>• Качество на тесте:</a:t>
+              <a:t>Справа — значимость признаков</a:t>
             </a:r>
           </a:p>
           <a:p>
             <a:pPr/>
             <a:r>
               <a:rPr sz="1100"/>
-              <a:t>   ROC-AUC = 0.917</a:t>
-            </a:r>
-          </a:p>
-          <a:p>
-            <a:pPr/>
-            <a:r>
-              <a:rPr sz="1100"/>
-              <a:t>   F1-мера = 0.77</a:t>
-            </a:r>
-          </a:p>
-          <a:p>
-            <a:pPr/>
-            <a:r>
-              <a:rPr sz="1100"/>
-              <a:t>   Полнота = 0.67</a:t>
+              <a:t>по permutation importance.</a:t>
             </a:r>
           </a:p>
           <a:p>
@@ -7412,28 +7405,21 @@
             <a:pPr/>
             <a:r>
               <a:rPr sz="1100"/>
-              <a:t>• Почему выиграл:</a:t>
+              <a:t>Страна вырывается вперёд:</a:t>
             </a:r>
           </a:p>
           <a:p>
             <a:pPr/>
             <a:r>
               <a:rPr sz="1100"/>
-              <a:t>   ловит нелинейные связи,</a:t>
+              <a:t>через целевое кодирование она</a:t>
             </a:r>
           </a:p>
           <a:p>
             <a:pPr/>
             <a:r>
               <a:rPr sz="1100"/>
-              <a:t>   быстрее случайного леса,</a:t>
-            </a:r>
-          </a:p>
-          <a:p>
-            <a:pPr/>
-            <a:r>
-              <a:rPr sz="1100"/>
-              <a:t>   стабилен по фолдам.</a:t>
+              <a:t>несёт уникальную информацию.</a:t>
             </a:r>
           </a:p>
           <a:p>
@@ -7447,21 +7433,28 @@
             <a:pPr/>
             <a:r>
               <a:rPr sz="1100"/>
-              <a:t>• Параметры: 300 итераций,</a:t>
+              <a:t>Срок до заезда коррелирует</a:t>
             </a:r>
           </a:p>
           <a:p>
             <a:pPr/>
             <a:r>
               <a:rPr sz="1100"/>
-              <a:t>   скорость обучения 0.05,</a:t>
+              <a:t>с каналом и сегментом — часть</a:t>
             </a:r>
           </a:p>
           <a:p>
             <a:pPr/>
             <a:r>
               <a:rPr sz="1100"/>
-              <a:t>   глубина дерева 8.</a:t>
+              <a:t>его сигнала модель</a:t>
+            </a:r>
+          </a:p>
+          <a:p>
+            <a:pPr/>
+            <a:r>
+              <a:rPr sz="1100"/>
+              <a:t>восстанавливает через них.</a:t>
             </a:r>
           </a:p>
         </p:txBody>
@@ -8068,7 +8061,7 @@
                   <a:srgbClr val="953734"/>
                 </a:solidFill>
               </a:rPr>
-              <a:t>Как развернуть и чем рискуем</a:t>
+              <a:t>Ограничения модели</a:t>
             </a:r>
           </a:p>
         </p:txBody>
@@ -8081,36 +8074,7 @@
         </p:nvSpPr>
         <p:spPr>
           <a:xfrm>
-            <a:off x="323528" y="770000"/>
-            <a:ext cx="8500000" cy="380000"/>
-          </a:xfrm>
-          <a:prstGeom prst="rect">
-            <a:avLst/>
-          </a:prstGeom>
-          <a:noFill/>
-        </p:spPr>
-        <p:txBody>
-          <a:bodyPr wrap="square">
-            <a:spAutoFit/>
-          </a:bodyPr>
-          <a:lstStyle/>
-          <a:p>
-            <a:r>
-              <a:rPr sz="1400" b="0"/>
-              <a:t>Что нужно для работы в продакшене и слабые места модели</a:t>
-            </a:r>
-          </a:p>
-        </p:txBody>
-      </p:sp>
-      <p:sp>
-        <p:nvSpPr>
-          <p:cNvPr id="5" name="TextBox 4"/>
-          <p:cNvSpPr txBox="1"/>
-          <p:nvPr/>
-        </p:nvSpPr>
-        <p:spPr>
-          <a:xfrm>
-            <a:off x="323528" y="1200000"/>
+            <a:off x="323528" y="1059582"/>
             <a:ext cx="8500000" cy="4000000"/>
           </a:xfrm>
           <a:prstGeom prst="rect">
@@ -8126,113 +8090,113 @@
           <a:p>
             <a:pPr/>
             <a:r>
-              <a:rPr sz="1200"/>
-              <a:t>• Развёртывание:</a:t>
-            </a:r>
-          </a:p>
-          <a:p>
-            <a:pPr/>
-            <a:r>
-              <a:rPr sz="1200"/>
-              <a:t>   простой веб-сервис (например, FastAPI) с командой /predict,</a:t>
-            </a:r>
-          </a:p>
-          <a:p>
-            <a:pPr/>
-            <a:r>
-              <a:rPr sz="1200"/>
-              <a:t>   модель загружается из файла в память при старте сервиса,</a:t>
-            </a:r>
-          </a:p>
-          <a:p>
-            <a:pPr/>
-            <a:r>
-              <a:rPr sz="1200"/>
-              <a:t>   время ответа меньше 50 мс на бронь,</a:t>
-            </a:r>
-          </a:p>
-          <a:p>
-            <a:pPr/>
-            <a:r>
-              <a:rPr sz="1200"/>
-              <a:t>   раз в сутки пересчёт по активным бронированиям,</a:t>
-            </a:r>
-          </a:p>
-          <a:p>
-            <a:pPr/>
-            <a:r>
-              <a:rPr sz="1200"/>
-              <a:t>   мониторинг смещения распределений признаков,</a:t>
-            </a:r>
-          </a:p>
-          <a:p>
-            <a:pPr/>
-            <a:r>
-              <a:rPr sz="1200"/>
-              <a:t>   переобучение раз в квартал на скользящем окне.</a:t>
-            </a:r>
-          </a:p>
-          <a:p>
-            <a:pPr/>
-            <a:r>
-              <a:rPr sz="1200"/>
+              <a:rPr sz="1300"/>
+              <a:t>1. Перенос на другие отели.</a:t>
+            </a:r>
+          </a:p>
+          <a:p>
+            <a:pPr/>
+            <a:r>
+              <a:rPr sz="1300"/>
+              <a:t>   Обучались на двух отелях в Португалии.</a:t>
+            </a:r>
+          </a:p>
+          <a:p>
+            <a:pPr/>
+            <a:r>
+              <a:rPr sz="1300"/>
+              <a:t>   На сетевой отель в Германии или Азии может не перенестись —</a:t>
+            </a:r>
+          </a:p>
+          <a:p>
+            <a:pPr/>
+            <a:r>
+              <a:rPr sz="1300"/>
+              <a:t>   структура каналов и поведение клиентов другие.</a:t>
+            </a:r>
+          </a:p>
+          <a:p>
+            <a:pPr/>
+            <a:r>
+              <a:rPr sz="1300"/>
               <a:t/>
             </a:r>
           </a:p>
           <a:p>
             <a:pPr/>
             <a:r>
-              <a:rPr sz="1200"/>
-              <a:t>• Главные риски:</a:t>
-            </a:r>
-          </a:p>
-          <a:p>
-            <a:pPr/>
-            <a:r>
-              <a:rPr sz="1200"/>
-              <a:t>   1. Перенос на другие отели. Обучались на двух отелях</a:t>
-            </a:r>
-          </a:p>
-          <a:p>
-            <a:pPr/>
-            <a:r>
-              <a:rPr sz="1200"/>
-              <a:t>      в Португалии — на сетевой отель в Германии может</a:t>
-            </a:r>
-          </a:p>
-          <a:p>
-            <a:pPr/>
-            <a:r>
-              <a:rPr sz="1200"/>
-              <a:t>      не перенестись.</a:t>
-            </a:r>
-          </a:p>
-          <a:p>
-            <a:pPr/>
-            <a:r>
-              <a:rPr sz="1200"/>
-              <a:t>   2. Смещение во времени. Данные 2015 – 2017 годов,</a:t>
-            </a:r>
-          </a:p>
-          <a:p>
-            <a:pPr/>
-            <a:r>
-              <a:rPr sz="1200"/>
-              <a:t>      после ковида клиенты ведут себя иначе.</a:t>
-            </a:r>
-          </a:p>
-          <a:p>
-            <a:pPr/>
-            <a:r>
-              <a:rPr sz="1200"/>
-              <a:t>   3. Новая страна. Если в обучении её не было, целевое</a:t>
-            </a:r>
-          </a:p>
-          <a:p>
-            <a:pPr/>
-            <a:r>
-              <a:rPr sz="1200"/>
-              <a:t>      кодирование даёт среднее по миру — точность падает.</a:t>
+              <a:rPr sz="1300"/>
+              <a:t>2. Смещение во времени.</a:t>
+            </a:r>
+          </a:p>
+          <a:p>
+            <a:pPr/>
+            <a:r>
+              <a:rPr sz="1300"/>
+              <a:t>   Данные 2015 – 2017 годов. После ковида клиенты ведут себя иначе:</a:t>
+            </a:r>
+          </a:p>
+          <a:p>
+            <a:pPr/>
+            <a:r>
+              <a:rPr sz="1300"/>
+              <a:t>   гибкие условия отмены стали нормой, доля отмен в индустрии выросла.</a:t>
+            </a:r>
+          </a:p>
+          <a:p>
+            <a:pPr/>
+            <a:r>
+              <a:rPr sz="1300"/>
+              <a:t/>
+            </a:r>
+          </a:p>
+          <a:p>
+            <a:pPr/>
+            <a:r>
+              <a:rPr sz="1300"/>
+              <a:t>3. Новая страна.</a:t>
+            </a:r>
+          </a:p>
+          <a:p>
+            <a:pPr/>
+            <a:r>
+              <a:rPr sz="1300"/>
+              <a:t>   Если страны не было в обучении, целевое кодирование даёт среднее</a:t>
+            </a:r>
+          </a:p>
+          <a:p>
+            <a:pPr/>
+            <a:r>
+              <a:rPr sz="1300"/>
+              <a:t>   по миру — точность для таких броней непредсказуемо хуже.</a:t>
+            </a:r>
+          </a:p>
+          <a:p>
+            <a:pPr/>
+            <a:r>
+              <a:rPr sz="1300"/>
+              <a:t/>
+            </a:r>
+          </a:p>
+          <a:p>
+            <a:pPr/>
+            <a:r>
+              <a:rPr sz="1300"/>
+              <a:t>Прототип развёрнут как Streamlit-приложение (предыдущий слайд).</a:t>
+            </a:r>
+          </a:p>
+          <a:p>
+            <a:pPr/>
+            <a:r>
+              <a:rPr sz="1300"/>
+              <a:t>Для продакшена — веб-сервис, мониторинг распределений признаков</a:t>
+            </a:r>
+          </a:p>
+          <a:p>
+            <a:pPr/>
+            <a:r>
+              <a:rPr sz="1300"/>
+              <a:t>и переобучение раз в квартал.</a:t>
             </a:r>
           </a:p>
         </p:txBody>
@@ -9035,7 +8999,7 @@
                   <a:srgbClr val="953734"/>
                 </a:solidFill>
               </a:rPr>
-              <a:t>Главный сигнал: срок до заезда</a:t>
+              <a:t>Срок до заезда — сильнейший одиночный сигнал</a:t>
             </a:r>
           </a:p>
         </p:txBody>
@@ -9064,85 +9028,92 @@
           <a:p>
             <a:pPr/>
             <a:r>
-              <a:rPr sz="1300"/>
-              <a:t>• Чем дольше клиент ждёт</a:t>
-            </a:r>
-          </a:p>
-          <a:p>
-            <a:pPr/>
-            <a:r>
-              <a:rPr sz="1300"/>
-              <a:t>   до заезда, тем чаще отменяет</a:t>
-            </a:r>
-          </a:p>
-          <a:p>
-            <a:pPr/>
-            <a:r>
-              <a:rPr sz="1300"/>
+              <a:rPr sz="1200"/>
+              <a:t>Если смотреть на один признак</a:t>
+            </a:r>
+          </a:p>
+          <a:p>
+            <a:pPr/>
+            <a:r>
+              <a:rPr sz="1200"/>
+              <a:t>отдельно — это самый сильный.</a:t>
+            </a:r>
+          </a:p>
+          <a:p>
+            <a:pPr/>
+            <a:r>
+              <a:rPr sz="1200"/>
               <a:t/>
             </a:r>
           </a:p>
           <a:p>
             <a:pPr/>
             <a:r>
-              <a:rPr sz="1300"/>
-              <a:t>• Брони, оформленные за неделю</a:t>
-            </a:r>
-          </a:p>
-          <a:p>
-            <a:pPr/>
-            <a:r>
-              <a:rPr sz="1300"/>
-              <a:t>   до заезда, отменяют примерно</a:t>
-            </a:r>
-          </a:p>
-          <a:p>
-            <a:pPr/>
-            <a:r>
-              <a:rPr sz="1300"/>
+              <a:rPr sz="1200"/>
+              <a:t>• Брони за неделю до заезда</a:t>
+            </a:r>
+          </a:p>
+          <a:p>
+            <a:pPr/>
+            <a:r>
+              <a:rPr sz="1200"/>
+              <a:t>   отменяют примерно</a:t>
+            </a:r>
+          </a:p>
+          <a:p>
+            <a:pPr/>
+            <a:r>
+              <a:rPr sz="1200"/>
               <a:t>   в 10 % случаев</a:t>
             </a:r>
           </a:p>
           <a:p>
             <a:pPr/>
             <a:r>
-              <a:rPr sz="1300"/>
+              <a:rPr sz="1200"/>
               <a:t/>
             </a:r>
           </a:p>
           <a:p>
             <a:pPr/>
             <a:r>
-              <a:rPr sz="1300"/>
+              <a:rPr sz="1200"/>
               <a:t>• Брони за 4–6 месяцев —</a:t>
             </a:r>
           </a:p>
           <a:p>
             <a:pPr/>
             <a:r>
-              <a:rPr sz="1300"/>
-              <a:t>   отменяют почти в половине</a:t>
-            </a:r>
-          </a:p>
-          <a:p>
-            <a:pPr/>
-            <a:r>
-              <a:rPr sz="1300"/>
+              <a:rPr sz="1200"/>
+              <a:t>   почти в половине случаев</a:t>
+            </a:r>
+          </a:p>
+          <a:p>
+            <a:pPr/>
+            <a:r>
+              <a:rPr sz="1200"/>
               <a:t/>
             </a:r>
           </a:p>
           <a:p>
             <a:pPr/>
             <a:r>
-              <a:rPr sz="1300"/>
-              <a:t>• Это самый сильный</a:t>
-            </a:r>
-          </a:p>
-          <a:p>
-            <a:pPr/>
-            <a:r>
-              <a:rPr sz="1300"/>
-              <a:t>   отдельный признак в данных</a:t>
+              <a:rPr sz="1200"/>
+              <a:t>• В модели вместе с другими</a:t>
+            </a:r>
+          </a:p>
+          <a:p>
+            <a:pPr/>
+            <a:r>
+              <a:rPr sz="1200"/>
+              <a:t>   признаками порядок меняется</a:t>
+            </a:r>
+          </a:p>
+          <a:p>
+            <a:pPr/>
+            <a:r>
+              <a:rPr sz="1200"/>
+              <a:t>   (см. слайд про важность).</a:t>
             </a:r>
           </a:p>
         </p:txBody>

</xml_diff>